<commit_message>
Update and corrections to the feedback guide, add more notes from a tester.
</commit_message>
<xml_diff>
--- a/Prototype User Feedback Guide.pptx
+++ b/Prototype User Feedback Guide.pptx
@@ -345,7 +345,7 @@
             <a:fld id="{B61BEF0D-F0BB-DE4B-95CE-6DB70DBA9567}" type="datetimeFigureOut">
               <a:rPr lang="en-US" dirty="0"/>
               <a:pPr/>
-              <a:t>10/18/2026</a:t>
+              <a:t>10/20/2026</a:t>
             </a:fld>
             <a:endParaRPr lang="en-US" dirty="0"/>
           </a:p>
@@ -676,7 +676,7 @@
             <a:fld id="{B61BEF0D-F0BB-DE4B-95CE-6DB70DBA9567}" type="datetimeFigureOut">
               <a:rPr lang="en-US" dirty="0"/>
               <a:pPr/>
-              <a:t>10/18/2026</a:t>
+              <a:t>10/20/2026</a:t>
             </a:fld>
             <a:endParaRPr lang="en-US" dirty="0"/>
           </a:p>
@@ -951,7 +951,7 @@
             <a:fld id="{B61BEF0D-F0BB-DE4B-95CE-6DB70DBA9567}" type="datetimeFigureOut">
               <a:rPr lang="en-US" dirty="0"/>
               <a:pPr/>
-              <a:t>10/18/2026</a:t>
+              <a:t>10/20/2026</a:t>
             </a:fld>
             <a:endParaRPr lang="en-US" dirty="0"/>
           </a:p>
@@ -1516,7 +1516,7 @@
             <a:fld id="{B61BEF0D-F0BB-DE4B-95CE-6DB70DBA9567}" type="datetimeFigureOut">
               <a:rPr lang="en-US" dirty="0"/>
               <a:pPr/>
-              <a:t>10/18/2026</a:t>
+              <a:t>10/20/2026</a:t>
             </a:fld>
             <a:endParaRPr lang="en-US" dirty="0"/>
           </a:p>
@@ -1791,7 +1791,7 @@
             <a:fld id="{B61BEF0D-F0BB-DE4B-95CE-6DB70DBA9567}" type="datetimeFigureOut">
               <a:rPr lang="en-US" dirty="0"/>
               <a:pPr/>
-              <a:t>10/18/2026</a:t>
+              <a:t>10/20/2026</a:t>
             </a:fld>
             <a:endParaRPr lang="en-US" dirty="0"/>
           </a:p>
@@ -2350,7 +2350,7 @@
             <a:fld id="{B61BEF0D-F0BB-DE4B-95CE-6DB70DBA9567}" type="datetimeFigureOut">
               <a:rPr lang="en-US" dirty="0"/>
               <a:pPr/>
-              <a:t>10/18/2026</a:t>
+              <a:t>10/20/2026</a:t>
             </a:fld>
             <a:endParaRPr lang="en-US" dirty="0"/>
           </a:p>
@@ -2674,7 +2674,7 @@
             <a:fld id="{B61BEF0D-F0BB-DE4B-95CE-6DB70DBA9567}" type="datetimeFigureOut">
               <a:rPr lang="en-US" dirty="0"/>
               <a:pPr/>
-              <a:t>10/18/2026</a:t>
+              <a:t>10/20/2026</a:t>
             </a:fld>
             <a:endParaRPr lang="en-US" dirty="0"/>
           </a:p>
@@ -2848,7 +2848,7 @@
             <a:fld id="{B61BEF0D-F0BB-DE4B-95CE-6DB70DBA9567}" type="datetimeFigureOut">
               <a:rPr lang="en-US" dirty="0"/>
               <a:pPr/>
-              <a:t>10/18/2026</a:t>
+              <a:t>10/20/2026</a:t>
             </a:fld>
             <a:endParaRPr lang="en-US" dirty="0"/>
           </a:p>
@@ -3083,7 +3083,7 @@
             <a:fld id="{B61BEF0D-F0BB-DE4B-95CE-6DB70DBA9567}" type="datetimeFigureOut">
               <a:rPr lang="en-US" dirty="0"/>
               <a:pPr/>
-              <a:t>10/18/2026</a:t>
+              <a:t>10/20/2026</a:t>
             </a:fld>
             <a:endParaRPr lang="en-US" dirty="0"/>
           </a:p>
@@ -3280,7 +3280,7 @@
             <a:fld id="{B61BEF0D-F0BB-DE4B-95CE-6DB70DBA9567}" type="datetimeFigureOut">
               <a:rPr lang="en-US" dirty="0"/>
               <a:pPr/>
-              <a:t>10/18/2026</a:t>
+              <a:t>10/20/2026</a:t>
             </a:fld>
             <a:endParaRPr lang="en-US" dirty="0"/>
           </a:p>
@@ -3553,7 +3553,7 @@
             <a:fld id="{B61BEF0D-F0BB-DE4B-95CE-6DB70DBA9567}" type="datetimeFigureOut">
               <a:rPr lang="en-US" dirty="0"/>
               <a:pPr/>
-              <a:t>10/18/2026</a:t>
+              <a:t>10/20/2026</a:t>
             </a:fld>
             <a:endParaRPr lang="en-US" dirty="0"/>
           </a:p>
@@ -3816,7 +3816,7 @@
             <a:fld id="{B61BEF0D-F0BB-DE4B-95CE-6DB70DBA9567}" type="datetimeFigureOut">
               <a:rPr lang="en-US" dirty="0"/>
               <a:pPr/>
-              <a:t>10/18/2026</a:t>
+              <a:t>10/20/2026</a:t>
             </a:fld>
             <a:endParaRPr lang="en-US" dirty="0"/>
           </a:p>
@@ -4187,7 +4187,7 @@
             <a:fld id="{B61BEF0D-F0BB-DE4B-95CE-6DB70DBA9567}" type="datetimeFigureOut">
               <a:rPr lang="en-US" dirty="0"/>
               <a:pPr/>
-              <a:t>10/18/2026</a:t>
+              <a:t>10/20/2026</a:t>
             </a:fld>
             <a:endParaRPr lang="en-US" dirty="0"/>
           </a:p>
@@ -4332,7 +4332,7 @@
             <a:fld id="{B61BEF0D-F0BB-DE4B-95CE-6DB70DBA9567}" type="datetimeFigureOut">
               <a:rPr lang="en-US" dirty="0"/>
               <a:pPr/>
-              <a:t>10/18/2026</a:t>
+              <a:t>10/20/2026</a:t>
             </a:fld>
             <a:endParaRPr lang="en-US" dirty="0"/>
           </a:p>
@@ -4454,7 +4454,7 @@
             <a:fld id="{B61BEF0D-F0BB-DE4B-95CE-6DB70DBA9567}" type="datetimeFigureOut">
               <a:rPr lang="en-US" dirty="0"/>
               <a:pPr/>
-              <a:t>10/18/2026</a:t>
+              <a:t>10/20/2026</a:t>
             </a:fld>
             <a:endParaRPr lang="en-US" dirty="0"/>
           </a:p>
@@ -4736,7 +4736,7 @@
             <a:fld id="{B61BEF0D-F0BB-DE4B-95CE-6DB70DBA9567}" type="datetimeFigureOut">
               <a:rPr lang="en-US" dirty="0"/>
               <a:pPr/>
-              <a:t>10/18/2026</a:t>
+              <a:t>10/20/2026</a:t>
             </a:fld>
             <a:endParaRPr lang="en-US" dirty="0"/>
           </a:p>
@@ -5057,7 +5057,7 @@
             <a:fld id="{B61BEF0D-F0BB-DE4B-95CE-6DB70DBA9567}" type="datetimeFigureOut">
               <a:rPr lang="en-US" dirty="0"/>
               <a:pPr/>
-              <a:t>10/18/2026</a:t>
+              <a:t>10/20/2026</a:t>
             </a:fld>
             <a:endParaRPr lang="en-US" dirty="0"/>
           </a:p>
@@ -5268,7 +5268,7 @@
             <a:fld id="{B61BEF0D-F0BB-DE4B-95CE-6DB70DBA9567}" type="datetimeFigureOut">
               <a:rPr lang="en-US" dirty="0"/>
               <a:pPr/>
-              <a:t>10/18/2026</a:t>
+              <a:t>10/20/2026</a:t>
             </a:fld>
             <a:endParaRPr lang="en-US" dirty="0"/>
           </a:p>
@@ -5924,33 +5924,137 @@
         </p:nvSpPr>
         <p:spPr>
           <a:xfrm>
-            <a:off x="685801" y="2142067"/>
-            <a:ext cx="10131425" cy="4294244"/>
+            <a:off x="685801" y="1735462"/>
+            <a:ext cx="10131425" cy="4700849"/>
           </a:xfrm>
         </p:spPr>
         <p:txBody>
           <a:bodyPr anchor="t">
-            <a:normAutofit fontScale="92500" lnSpcReduction="10000"/>
+            <a:normAutofit fontScale="85000" lnSpcReduction="20000"/>
           </a:bodyPr>
           <a:lstStyle/>
           <a:p>
             <a:r>
+              <a:rPr lang="en-GB" noProof="0" dirty="0"/>
+              <a:t>Controls like in </a:t>
+            </a:r>
+            <a:r>
+              <a:rPr lang="en-GB" noProof="0" dirty="0" err="1"/>
+              <a:t>Elite:Dangerous</a:t>
+            </a:r>
+            <a:endParaRPr lang="en-GB" noProof="0" dirty="0"/>
+          </a:p>
+          <a:p>
+            <a:r>
+              <a:rPr lang="en-GB" noProof="0" dirty="0"/>
+              <a:t>That means:</a:t>
+            </a:r>
+          </a:p>
+          <a:p>
+            <a:pPr lvl="1"/>
+            <a:r>
+              <a:rPr lang="en-GB" noProof="0" dirty="0"/>
+              <a:t>W/S Forward/Back</a:t>
+            </a:r>
+          </a:p>
+          <a:p>
+            <a:pPr lvl="1"/>
+            <a:r>
+              <a:rPr lang="en-GB" noProof="0" dirty="0"/>
+              <a:t>Q/E Left/Right</a:t>
+            </a:r>
+          </a:p>
+          <a:p>
+            <a:pPr lvl="1"/>
+            <a:r>
+              <a:rPr lang="en-GB" noProof="0" dirty="0"/>
+              <a:t>R/F Up/Down</a:t>
+            </a:r>
+          </a:p>
+          <a:p>
+            <a:pPr lvl="1"/>
+            <a:r>
+              <a:rPr lang="en-GB" noProof="0" dirty="0"/>
+              <a:t>A/D is either Yaw or Roll (Set it up)</a:t>
+            </a:r>
+          </a:p>
+          <a:p>
+            <a:pPr lvl="1"/>
+            <a:r>
+              <a:rPr lang="en-GB" noProof="0" dirty="0"/>
+              <a:t>Remaining of Pitch/Yaw/Roll on mouse, OR with KB-only controls, on I/K and J/L</a:t>
+            </a:r>
+          </a:p>
+          <a:p>
+            <a:pPr lvl="1"/>
+            <a:r>
+              <a:rPr lang="en-GB" noProof="0" dirty="0"/>
+              <a:t>There is also a control scheme reminiscent of </a:t>
+            </a:r>
+            <a:r>
+              <a:rPr lang="en-GB" i="1" noProof="0" dirty="0" err="1"/>
+              <a:t>Kerbal</a:t>
+            </a:r>
+            <a:r>
+              <a:rPr lang="en-GB" i="1" noProof="0" dirty="0"/>
+              <a:t> Space Program</a:t>
+            </a:r>
+            <a:r>
+              <a:rPr lang="en-GB" noProof="0" dirty="0"/>
+              <a:t> (Shift/Ctrl for Forward, Vertical, Lateral on IJKL, Roll on Q/E, Yaw on A/D and Pitch on W/S</a:t>
+            </a:r>
+          </a:p>
+          <a:p>
+            <a:r>
+              <a:rPr lang="en-GB" noProof="0" dirty="0"/>
+              <a:t>Backspace will </a:t>
+            </a:r>
+            <a:r>
+              <a:rPr lang="en-GB" i="1" noProof="0" dirty="0"/>
+              <a:t>restart </a:t>
+            </a:r>
+            <a:r>
+              <a:rPr lang="en-GB" noProof="0" dirty="0"/>
+              <a:t>a level, Escape brings you back to the menu.</a:t>
+            </a:r>
+          </a:p>
+          <a:p>
+            <a:r>
+              <a:rPr lang="en-GB" noProof="0" dirty="0"/>
+              <a:t>How to play?</a:t>
+            </a:r>
+          </a:p>
+          <a:p>
+            <a:pPr lvl="1"/>
+            <a:r>
+              <a:rPr lang="en-GB" noProof="0" dirty="0"/>
+              <a:t>You can fly in the flight test to test the handling (Including a handy obstacle field)</a:t>
+            </a:r>
+          </a:p>
+          <a:p>
+            <a:pPr lvl="1"/>
+            <a:r>
+              <a:rPr lang="en-GB" noProof="0" dirty="0"/>
+              <a:t>Or try the prototype level (Pass through all the checkpoint rings that have the translucent barrier and into the finish!)</a:t>
+            </a:r>
+          </a:p>
+          <a:p>
+            <a:pPr lvl="1"/>
+            <a:r>
+              <a:rPr lang="en-GB" noProof="0" dirty="0"/>
+              <a:t>Try the different control options! Ask if it‘s unclear (They are mostly internal names for now)</a:t>
+            </a:r>
+            <a:endParaRPr lang="cs-CZ" noProof="0" dirty="0"/>
+          </a:p>
+          <a:p>
+            <a:pPr lvl="1"/>
+            <a:r>
               <a:rPr lang="cs-CZ" dirty="0"/>
-              <a:t>Controls </a:t>
+              <a:t>I </a:t>
             </a:r>
             <a:r>
               <a:rPr lang="cs-CZ" dirty="0" err="1"/>
-              <a:t>like</a:t>
-            </a:r>
-            <a:r>
-              <a:rPr lang="cs-CZ" dirty="0"/>
-              <a:t> in E:D</a:t>
-            </a:r>
-          </a:p>
-          <a:p>
-            <a:r>
-              <a:rPr lang="cs-CZ" dirty="0" err="1"/>
-              <a:t>That</a:t>
+              <a:t>recommend</a:t>
             </a:r>
             <a:r>
               <a:rPr lang="cs-CZ" dirty="0"/>
@@ -5958,61 +6062,7 @@
             </a:r>
             <a:r>
               <a:rPr lang="cs-CZ" dirty="0" err="1"/>
-              <a:t>means</a:t>
-            </a:r>
-            <a:r>
-              <a:rPr lang="cs-CZ" dirty="0"/>
-              <a:t>:</a:t>
-            </a:r>
-          </a:p>
-          <a:p>
-            <a:pPr lvl="1"/>
-            <a:r>
-              <a:rPr lang="cs-CZ" dirty="0"/>
-              <a:t>W/S Forward/</a:t>
-            </a:r>
-            <a:r>
-              <a:rPr lang="cs-CZ" dirty="0" err="1"/>
-              <a:t>Back</a:t>
-            </a:r>
-            <a:endParaRPr lang="cs-CZ" dirty="0"/>
-          </a:p>
-          <a:p>
-            <a:pPr lvl="1"/>
-            <a:r>
-              <a:rPr lang="cs-CZ" dirty="0"/>
-              <a:t>Q/E </a:t>
-            </a:r>
-            <a:r>
-              <a:rPr lang="cs-CZ" dirty="0" err="1"/>
-              <a:t>Left</a:t>
-            </a:r>
-            <a:r>
-              <a:rPr lang="cs-CZ" dirty="0"/>
-              <a:t>/</a:t>
-            </a:r>
-            <a:r>
-              <a:rPr lang="cs-CZ" dirty="0" err="1"/>
-              <a:t>Right</a:t>
-            </a:r>
-            <a:endParaRPr lang="cs-CZ" dirty="0"/>
-          </a:p>
-          <a:p>
-            <a:pPr lvl="1"/>
-            <a:r>
-              <a:rPr lang="cs-CZ" dirty="0"/>
-              <a:t>R/F Up/Down</a:t>
-            </a:r>
-          </a:p>
-          <a:p>
-            <a:pPr lvl="1"/>
-            <a:r>
-              <a:rPr lang="cs-CZ" dirty="0"/>
-              <a:t>A/D </a:t>
-            </a:r>
-            <a:r>
-              <a:rPr lang="cs-CZ" dirty="0" err="1"/>
-              <a:t>is</a:t>
+              <a:t>first</a:t>
             </a:r>
             <a:r>
               <a:rPr lang="cs-CZ" dirty="0"/>
@@ -6020,7 +6070,15 @@
             </a:r>
             <a:r>
               <a:rPr lang="cs-CZ" dirty="0" err="1"/>
-              <a:t>either</a:t>
+              <a:t>trying</a:t>
+            </a:r>
+            <a:r>
+              <a:rPr lang="cs-CZ" dirty="0"/>
+              <a:t> Mouse as </a:t>
+            </a:r>
+            <a:r>
+              <a:rPr lang="cs-CZ" dirty="0" err="1"/>
+              <a:t>rotation</a:t>
             </a:r>
             <a:r>
               <a:rPr lang="cs-CZ" dirty="0"/>
@@ -6028,7 +6086,23 @@
             </a:r>
             <a:r>
               <a:rPr lang="cs-CZ" dirty="0" err="1"/>
-              <a:t>Yaw</a:t>
+              <a:t>Velocity</a:t>
+            </a:r>
+            <a:r>
+              <a:rPr lang="cs-CZ" dirty="0"/>
+              <a:t>, FA-on, forward as </a:t>
+            </a:r>
+            <a:r>
+              <a:rPr lang="cs-CZ" dirty="0" err="1"/>
+              <a:t>throttle</a:t>
+            </a:r>
+            <a:r>
+              <a:rPr lang="cs-CZ" dirty="0"/>
+              <a:t>. </a:t>
+            </a:r>
+            <a:r>
+              <a:rPr lang="cs-CZ" dirty="0" err="1"/>
+              <a:t>Then</a:t>
             </a:r>
             <a:r>
               <a:rPr lang="cs-CZ" dirty="0"/>
@@ -6036,500 +6110,37 @@
             </a:r>
             <a:r>
               <a:rPr lang="cs-CZ" dirty="0" err="1"/>
-              <a:t>or</a:t>
+              <a:t>moving</a:t>
             </a:r>
             <a:r>
               <a:rPr lang="cs-CZ" dirty="0"/>
-              <a:t> </a:t>
+              <a:t> to FA-</a:t>
             </a:r>
             <a:r>
               <a:rPr lang="cs-CZ" dirty="0" err="1"/>
-              <a:t>Roll</a:t>
+              <a:t>off</a:t>
             </a:r>
             <a:r>
               <a:rPr lang="cs-CZ" dirty="0"/>
-              <a:t> (Set </a:t>
+              <a:t>, </a:t>
             </a:r>
             <a:r>
               <a:rPr lang="cs-CZ" dirty="0" err="1"/>
-              <a:t>it</a:t>
+              <a:t>Rotation</a:t>
             </a:r>
             <a:r>
               <a:rPr lang="cs-CZ" dirty="0"/>
-              <a:t> up)</a:t>
-            </a:r>
-          </a:p>
-          <a:p>
-            <a:pPr lvl="1"/>
+              <a:t> on KB </a:t>
+            </a:r>
             <a:r>
               <a:rPr lang="cs-CZ" dirty="0" err="1"/>
-              <a:t>Remaining</a:t>
+              <a:t>stabilized</a:t>
             </a:r>
             <a:r>
               <a:rPr lang="cs-CZ" dirty="0"/>
-              <a:t> </a:t>
-            </a:r>
-            <a:r>
-              <a:rPr lang="cs-CZ" dirty="0" err="1"/>
-              <a:t>of</a:t>
-            </a:r>
-            <a:r>
-              <a:rPr lang="cs-CZ" dirty="0"/>
-              <a:t> </a:t>
-            </a:r>
-            <a:r>
-              <a:rPr lang="cs-CZ" dirty="0" err="1"/>
-              <a:t>Pitch</a:t>
-            </a:r>
-            <a:r>
-              <a:rPr lang="cs-CZ" dirty="0"/>
-              <a:t>/</a:t>
-            </a:r>
-            <a:r>
-              <a:rPr lang="cs-CZ" dirty="0" err="1"/>
-              <a:t>Yaw</a:t>
-            </a:r>
-            <a:r>
-              <a:rPr lang="cs-CZ" dirty="0"/>
-              <a:t>/</a:t>
-            </a:r>
-            <a:r>
-              <a:rPr lang="cs-CZ" dirty="0" err="1"/>
-              <a:t>Roll</a:t>
-            </a:r>
-            <a:r>
-              <a:rPr lang="cs-CZ" dirty="0"/>
-              <a:t> on </a:t>
-            </a:r>
-            <a:r>
-              <a:rPr lang="cs-CZ" dirty="0" err="1"/>
-              <a:t>mouse</a:t>
-            </a:r>
-            <a:r>
-              <a:rPr lang="cs-CZ" dirty="0"/>
-              <a:t>, OR </a:t>
-            </a:r>
-            <a:r>
-              <a:rPr lang="cs-CZ" dirty="0" err="1"/>
-              <a:t>with</a:t>
-            </a:r>
-            <a:r>
-              <a:rPr lang="cs-CZ" dirty="0"/>
-              <a:t> KB-</a:t>
-            </a:r>
-            <a:r>
-              <a:rPr lang="cs-CZ" dirty="0" err="1"/>
-              <a:t>only</a:t>
-            </a:r>
-            <a:r>
-              <a:rPr lang="cs-CZ" dirty="0"/>
-              <a:t> </a:t>
-            </a:r>
-            <a:r>
-              <a:rPr lang="cs-CZ" dirty="0" err="1"/>
-              <a:t>controls</a:t>
-            </a:r>
-            <a:r>
-              <a:rPr lang="cs-CZ" dirty="0"/>
-              <a:t>, on I/K and J/L</a:t>
-            </a:r>
-          </a:p>
-          <a:p>
-            <a:r>
-              <a:rPr lang="cs-CZ" dirty="0" err="1"/>
-              <a:t>Backspace</a:t>
-            </a:r>
-            <a:r>
-              <a:rPr lang="cs-CZ" dirty="0"/>
-              <a:t> </a:t>
-            </a:r>
-            <a:r>
-              <a:rPr lang="cs-CZ" dirty="0" err="1"/>
-              <a:t>will</a:t>
-            </a:r>
-            <a:r>
-              <a:rPr lang="cs-CZ" dirty="0"/>
-              <a:t> </a:t>
-            </a:r>
-            <a:r>
-              <a:rPr lang="cs-CZ" i="1" dirty="0"/>
-              <a:t>restart </a:t>
-            </a:r>
-            <a:r>
-              <a:rPr lang="cs-CZ" dirty="0"/>
-              <a:t>a level, </a:t>
-            </a:r>
-            <a:r>
-              <a:rPr lang="cs-CZ" dirty="0" err="1"/>
-              <a:t>Escape</a:t>
-            </a:r>
-            <a:r>
-              <a:rPr lang="cs-CZ" dirty="0"/>
-              <a:t> </a:t>
-            </a:r>
-            <a:r>
-              <a:rPr lang="cs-CZ" dirty="0" err="1"/>
-              <a:t>brings</a:t>
-            </a:r>
-            <a:r>
-              <a:rPr lang="cs-CZ" dirty="0"/>
-              <a:t> </a:t>
-            </a:r>
-            <a:r>
-              <a:rPr lang="cs-CZ" dirty="0" err="1"/>
-              <a:t>you</a:t>
-            </a:r>
-            <a:r>
-              <a:rPr lang="cs-CZ" dirty="0"/>
-              <a:t> </a:t>
-            </a:r>
-            <a:r>
-              <a:rPr lang="cs-CZ" dirty="0" err="1"/>
-              <a:t>back</a:t>
-            </a:r>
-            <a:r>
-              <a:rPr lang="cs-CZ" dirty="0"/>
-              <a:t> to </a:t>
-            </a:r>
-            <a:r>
-              <a:rPr lang="cs-CZ" dirty="0" err="1"/>
-              <a:t>the</a:t>
-            </a:r>
-            <a:r>
-              <a:rPr lang="cs-CZ" dirty="0"/>
-              <a:t> menu.</a:t>
-            </a:r>
-          </a:p>
-          <a:p>
-            <a:r>
-              <a:rPr lang="cs-CZ" dirty="0" err="1"/>
-              <a:t>How</a:t>
-            </a:r>
-            <a:r>
-              <a:rPr lang="cs-CZ" dirty="0"/>
-              <a:t> to play?</a:t>
-            </a:r>
-          </a:p>
-          <a:p>
-            <a:pPr lvl="1"/>
-            <a:r>
-              <a:rPr lang="cs-CZ" dirty="0" err="1"/>
-              <a:t>You</a:t>
-            </a:r>
-            <a:r>
-              <a:rPr lang="cs-CZ" dirty="0"/>
-              <a:t> </a:t>
-            </a:r>
-            <a:r>
-              <a:rPr lang="cs-CZ" dirty="0" err="1"/>
-              <a:t>can</a:t>
-            </a:r>
-            <a:r>
-              <a:rPr lang="cs-CZ" dirty="0"/>
-              <a:t> </a:t>
-            </a:r>
-            <a:r>
-              <a:rPr lang="cs-CZ" dirty="0" err="1"/>
-              <a:t>fly</a:t>
-            </a:r>
-            <a:r>
-              <a:rPr lang="cs-CZ" dirty="0"/>
-              <a:t> in </a:t>
-            </a:r>
-            <a:r>
-              <a:rPr lang="cs-CZ" dirty="0" err="1"/>
-              <a:t>the</a:t>
-            </a:r>
-            <a:r>
-              <a:rPr lang="cs-CZ" dirty="0"/>
-              <a:t> </a:t>
-            </a:r>
-            <a:r>
-              <a:rPr lang="cs-CZ" dirty="0" err="1"/>
-              <a:t>flight</a:t>
-            </a:r>
-            <a:r>
-              <a:rPr lang="cs-CZ" dirty="0"/>
-              <a:t> test to test </a:t>
-            </a:r>
-            <a:r>
-              <a:rPr lang="cs-CZ" dirty="0" err="1"/>
-              <a:t>the</a:t>
-            </a:r>
-            <a:r>
-              <a:rPr lang="cs-CZ" dirty="0"/>
-              <a:t> </a:t>
-            </a:r>
-            <a:r>
-              <a:rPr lang="cs-CZ" dirty="0" err="1"/>
-              <a:t>handling</a:t>
-            </a:r>
-            <a:r>
-              <a:rPr lang="cs-CZ" dirty="0"/>
-              <a:t> (</a:t>
-            </a:r>
-            <a:r>
-              <a:rPr lang="cs-CZ" dirty="0" err="1"/>
-              <a:t>Including</a:t>
-            </a:r>
-            <a:r>
-              <a:rPr lang="cs-CZ" dirty="0"/>
-              <a:t> a handy </a:t>
-            </a:r>
-            <a:r>
-              <a:rPr lang="cs-CZ" dirty="0" err="1"/>
-              <a:t>obstacle</a:t>
-            </a:r>
-            <a:r>
-              <a:rPr lang="cs-CZ" dirty="0"/>
-              <a:t> </a:t>
-            </a:r>
-            <a:r>
-              <a:rPr lang="cs-CZ" dirty="0" err="1"/>
-              <a:t>field</a:t>
-            </a:r>
-            <a:r>
-              <a:rPr lang="cs-CZ" dirty="0"/>
-              <a:t>)</a:t>
-            </a:r>
-          </a:p>
-          <a:p>
-            <a:pPr lvl="1"/>
-            <a:r>
-              <a:rPr lang="cs-CZ" dirty="0"/>
-              <a:t>Or </a:t>
-            </a:r>
-            <a:r>
-              <a:rPr lang="cs-CZ" dirty="0" err="1"/>
-              <a:t>try</a:t>
-            </a:r>
-            <a:r>
-              <a:rPr lang="cs-CZ" dirty="0"/>
-              <a:t> </a:t>
-            </a:r>
-            <a:r>
-              <a:rPr lang="cs-CZ" dirty="0" err="1"/>
-              <a:t>the</a:t>
-            </a:r>
-            <a:r>
-              <a:rPr lang="cs-CZ" dirty="0"/>
-              <a:t> prototype level (</a:t>
-            </a:r>
-            <a:r>
-              <a:rPr lang="cs-CZ" dirty="0" err="1"/>
-              <a:t>Pass</a:t>
-            </a:r>
-            <a:r>
-              <a:rPr lang="cs-CZ" dirty="0"/>
-              <a:t> </a:t>
-            </a:r>
-            <a:r>
-              <a:rPr lang="cs-CZ" dirty="0" err="1"/>
-              <a:t>through</a:t>
-            </a:r>
-            <a:r>
-              <a:rPr lang="cs-CZ" dirty="0"/>
-              <a:t> </a:t>
-            </a:r>
-            <a:r>
-              <a:rPr lang="cs-CZ" dirty="0" err="1"/>
-              <a:t>all</a:t>
-            </a:r>
-            <a:r>
-              <a:rPr lang="cs-CZ" dirty="0"/>
-              <a:t> </a:t>
-            </a:r>
-            <a:r>
-              <a:rPr lang="cs-CZ" dirty="0" err="1"/>
-              <a:t>the</a:t>
-            </a:r>
-            <a:r>
-              <a:rPr lang="cs-CZ" dirty="0"/>
-              <a:t> checkpoint </a:t>
-            </a:r>
-            <a:r>
-              <a:rPr lang="cs-CZ" dirty="0" err="1"/>
-              <a:t>rings</a:t>
-            </a:r>
-            <a:r>
-              <a:rPr lang="cs-CZ" dirty="0"/>
-              <a:t> </a:t>
-            </a:r>
-            <a:r>
-              <a:rPr lang="cs-CZ" dirty="0" err="1"/>
-              <a:t>that</a:t>
-            </a:r>
-            <a:r>
-              <a:rPr lang="cs-CZ" dirty="0"/>
-              <a:t> </a:t>
-            </a:r>
-            <a:r>
-              <a:rPr lang="cs-CZ" dirty="0" err="1"/>
-              <a:t>have</a:t>
-            </a:r>
-            <a:r>
-              <a:rPr lang="cs-CZ" dirty="0"/>
-              <a:t> </a:t>
-            </a:r>
-            <a:r>
-              <a:rPr lang="cs-CZ" dirty="0" err="1"/>
-              <a:t>the</a:t>
-            </a:r>
-            <a:r>
-              <a:rPr lang="cs-CZ" dirty="0"/>
-              <a:t> </a:t>
-            </a:r>
-            <a:r>
-              <a:rPr lang="cs-CZ" dirty="0" err="1"/>
-              <a:t>translucent</a:t>
-            </a:r>
-            <a:r>
-              <a:rPr lang="cs-CZ" dirty="0"/>
-              <a:t> </a:t>
-            </a:r>
-            <a:r>
-              <a:rPr lang="cs-CZ" dirty="0" err="1"/>
-              <a:t>barrier</a:t>
-            </a:r>
-            <a:r>
-              <a:rPr lang="cs-CZ" dirty="0"/>
-              <a:t> and </a:t>
-            </a:r>
-            <a:r>
-              <a:rPr lang="cs-CZ" dirty="0" err="1"/>
-              <a:t>into</a:t>
-            </a:r>
-            <a:r>
-              <a:rPr lang="cs-CZ" dirty="0"/>
-              <a:t> </a:t>
-            </a:r>
-            <a:r>
-              <a:rPr lang="cs-CZ" dirty="0" err="1"/>
-              <a:t>the</a:t>
-            </a:r>
-            <a:r>
-              <a:rPr lang="cs-CZ" dirty="0"/>
-              <a:t> </a:t>
-            </a:r>
-            <a:r>
-              <a:rPr lang="cs-CZ" dirty="0" err="1"/>
-              <a:t>finish</a:t>
-            </a:r>
-            <a:r>
-              <a:rPr lang="cs-CZ" dirty="0"/>
-              <a:t>!)</a:t>
-            </a:r>
-          </a:p>
-          <a:p>
-            <a:pPr lvl="1"/>
-            <a:r>
-              <a:rPr lang="cs-CZ" dirty="0"/>
-              <a:t>Try </a:t>
-            </a:r>
-            <a:r>
-              <a:rPr lang="cs-CZ" dirty="0" err="1"/>
-              <a:t>the</a:t>
-            </a:r>
-            <a:r>
-              <a:rPr lang="cs-CZ" dirty="0"/>
-              <a:t> </a:t>
-            </a:r>
-            <a:r>
-              <a:rPr lang="cs-CZ" dirty="0" err="1"/>
-              <a:t>different</a:t>
-            </a:r>
-            <a:r>
-              <a:rPr lang="cs-CZ" dirty="0"/>
-              <a:t> </a:t>
-            </a:r>
-            <a:r>
-              <a:rPr lang="cs-CZ" dirty="0" err="1"/>
-              <a:t>control</a:t>
-            </a:r>
-            <a:r>
-              <a:rPr lang="cs-CZ" dirty="0"/>
-              <a:t> </a:t>
-            </a:r>
-            <a:r>
-              <a:rPr lang="cs-CZ" dirty="0" err="1"/>
-              <a:t>options</a:t>
-            </a:r>
-            <a:r>
-              <a:rPr lang="cs-CZ" dirty="0"/>
-              <a:t>! </a:t>
-            </a:r>
-            <a:r>
-              <a:rPr lang="cs-CZ" dirty="0" err="1"/>
-              <a:t>Ask</a:t>
-            </a:r>
-            <a:r>
-              <a:rPr lang="cs-CZ" dirty="0"/>
-              <a:t> </a:t>
-            </a:r>
-            <a:r>
-              <a:rPr lang="cs-CZ" dirty="0" err="1"/>
-              <a:t>if</a:t>
-            </a:r>
-            <a:r>
-              <a:rPr lang="cs-CZ" dirty="0"/>
-              <a:t> </a:t>
-            </a:r>
-            <a:r>
-              <a:rPr lang="cs-CZ" dirty="0" err="1"/>
-              <a:t>it‘s</a:t>
-            </a:r>
-            <a:r>
-              <a:rPr lang="cs-CZ" dirty="0"/>
-              <a:t> </a:t>
-            </a:r>
-            <a:r>
-              <a:rPr lang="cs-CZ" dirty="0" err="1"/>
-              <a:t>unclear</a:t>
-            </a:r>
-            <a:r>
-              <a:rPr lang="cs-CZ" dirty="0"/>
-              <a:t> (They are </a:t>
-            </a:r>
-            <a:r>
-              <a:rPr lang="cs-CZ" dirty="0" err="1"/>
-              <a:t>mostly</a:t>
-            </a:r>
-            <a:r>
-              <a:rPr lang="cs-CZ" dirty="0"/>
-              <a:t> </a:t>
-            </a:r>
-            <a:r>
-              <a:rPr lang="cs-CZ" dirty="0" err="1"/>
-              <a:t>internal</a:t>
-            </a:r>
-            <a:r>
-              <a:rPr lang="cs-CZ" dirty="0"/>
-              <a:t> </a:t>
-            </a:r>
-            <a:r>
-              <a:rPr lang="cs-CZ" dirty="0" err="1"/>
-              <a:t>names</a:t>
-            </a:r>
-            <a:r>
-              <a:rPr lang="cs-CZ" dirty="0"/>
-              <a:t> </a:t>
-            </a:r>
-            <a:r>
-              <a:rPr lang="cs-CZ" dirty="0" err="1"/>
-              <a:t>for</a:t>
-            </a:r>
-            <a:r>
-              <a:rPr lang="cs-CZ" dirty="0"/>
-              <a:t> </a:t>
-            </a:r>
-            <a:r>
-              <a:rPr lang="cs-CZ" dirty="0" err="1"/>
-              <a:t>now</a:t>
-            </a:r>
-            <a:r>
-              <a:rPr lang="cs-CZ" dirty="0"/>
-              <a:t>)</a:t>
-            </a:r>
+              <a:t>.</a:t>
+            </a:r>
+            <a:endParaRPr lang="en-GB" noProof="0" dirty="0"/>
           </a:p>
           <a:p>
             <a:pPr lvl="1"/>
@@ -6576,7 +6187,7 @@
         </p:blipFill>
         <p:spPr bwMode="auto">
           <a:xfrm>
-            <a:off x="7501632" y="1735462"/>
+            <a:off x="7386962" y="1433621"/>
             <a:ext cx="4119237" cy="2317071"/>
           </a:xfrm>
           <a:prstGeom prst="rect">
@@ -6712,800 +6323,91 @@
           <a:lstStyle/>
           <a:p>
             <a:r>
-              <a:rPr lang="cs-CZ" dirty="0" err="1"/>
-              <a:t>Anything</a:t>
-            </a:r>
-            <a:r>
-              <a:rPr lang="cs-CZ" dirty="0"/>
-              <a:t> </a:t>
-            </a:r>
-            <a:r>
-              <a:rPr lang="cs-CZ" dirty="0" err="1"/>
-              <a:t>you</a:t>
-            </a:r>
-            <a:r>
-              <a:rPr lang="cs-CZ" dirty="0"/>
-              <a:t> </a:t>
-            </a:r>
-            <a:r>
-              <a:rPr lang="cs-CZ" dirty="0" err="1"/>
-              <a:t>think</a:t>
-            </a:r>
-            <a:r>
-              <a:rPr lang="cs-CZ" dirty="0"/>
-              <a:t> </a:t>
-            </a:r>
-            <a:r>
-              <a:rPr lang="cs-CZ" dirty="0" err="1"/>
-              <a:t>about</a:t>
-            </a:r>
-            <a:r>
-              <a:rPr lang="cs-CZ" dirty="0"/>
-              <a:t> </a:t>
-            </a:r>
-            <a:r>
-              <a:rPr lang="cs-CZ" dirty="0" err="1"/>
-              <a:t>really</a:t>
-            </a:r>
-            <a:endParaRPr lang="cs-CZ" dirty="0"/>
-          </a:p>
-          <a:p>
-            <a:r>
-              <a:rPr lang="cs-CZ" dirty="0"/>
-              <a:t>But, most </a:t>
-            </a:r>
-            <a:r>
-              <a:rPr lang="cs-CZ" dirty="0" err="1"/>
-              <a:t>valuable</a:t>
-            </a:r>
-            <a:r>
-              <a:rPr lang="cs-CZ" dirty="0"/>
-              <a:t> </a:t>
-            </a:r>
-            <a:r>
-              <a:rPr lang="cs-CZ" dirty="0" err="1"/>
-              <a:t>would</a:t>
-            </a:r>
-            <a:r>
-              <a:rPr lang="cs-CZ" dirty="0"/>
-              <a:t> </a:t>
-            </a:r>
-            <a:r>
-              <a:rPr lang="cs-CZ" dirty="0" err="1"/>
-              <a:t>be</a:t>
-            </a:r>
-            <a:r>
-              <a:rPr lang="cs-CZ" dirty="0"/>
-              <a:t>:</a:t>
+              <a:rPr lang="en-GB" noProof="0" dirty="0"/>
+              <a:t>Anything you think about really</a:t>
+            </a:r>
+          </a:p>
+          <a:p>
+            <a:r>
+              <a:rPr lang="en-GB" noProof="0" dirty="0"/>
+              <a:t>But, most valuable would be:</a:t>
             </a:r>
           </a:p>
           <a:p>
             <a:pPr lvl="1"/>
             <a:r>
-              <a:rPr lang="cs-CZ" dirty="0" err="1"/>
-              <a:t>Ship</a:t>
-            </a:r>
-            <a:r>
-              <a:rPr lang="cs-CZ" dirty="0"/>
-              <a:t> </a:t>
-            </a:r>
-            <a:r>
-              <a:rPr lang="cs-CZ" dirty="0" err="1"/>
-              <a:t>handling</a:t>
-            </a:r>
-            <a:r>
-              <a:rPr lang="cs-CZ" dirty="0"/>
-              <a:t> (</a:t>
-            </a:r>
-            <a:r>
-              <a:rPr lang="cs-CZ" dirty="0" err="1"/>
-              <a:t>Does</a:t>
-            </a:r>
-            <a:r>
-              <a:rPr lang="cs-CZ" dirty="0"/>
-              <a:t> </a:t>
-            </a:r>
-            <a:r>
-              <a:rPr lang="cs-CZ" dirty="0" err="1"/>
-              <a:t>it</a:t>
-            </a:r>
-            <a:r>
-              <a:rPr lang="cs-CZ" dirty="0"/>
-              <a:t> slide </a:t>
-            </a:r>
-            <a:r>
-              <a:rPr lang="cs-CZ" dirty="0" err="1"/>
-              <a:t>too</a:t>
-            </a:r>
-            <a:r>
-              <a:rPr lang="cs-CZ" dirty="0"/>
-              <a:t> much? </a:t>
-            </a:r>
-            <a:r>
-              <a:rPr lang="cs-CZ" dirty="0" err="1"/>
-              <a:t>Is</a:t>
-            </a:r>
-            <a:r>
-              <a:rPr lang="cs-CZ" dirty="0"/>
-              <a:t> </a:t>
-            </a:r>
-            <a:r>
-              <a:rPr lang="cs-CZ" dirty="0" err="1"/>
-              <a:t>the</a:t>
-            </a:r>
-            <a:r>
-              <a:rPr lang="cs-CZ" dirty="0"/>
-              <a:t> </a:t>
-            </a:r>
-            <a:r>
-              <a:rPr lang="cs-CZ" dirty="0" err="1"/>
-              <a:t>acceleration</a:t>
-            </a:r>
-            <a:r>
-              <a:rPr lang="cs-CZ" dirty="0"/>
-              <a:t> </a:t>
-            </a:r>
-            <a:r>
-              <a:rPr lang="cs-CZ" dirty="0" err="1"/>
-              <a:t>too</a:t>
-            </a:r>
-            <a:r>
-              <a:rPr lang="cs-CZ" dirty="0"/>
-              <a:t> </a:t>
-            </a:r>
-            <a:r>
-              <a:rPr lang="cs-CZ" dirty="0" err="1"/>
-              <a:t>slow</a:t>
-            </a:r>
-            <a:r>
-              <a:rPr lang="cs-CZ" dirty="0"/>
-              <a:t>?</a:t>
+              <a:rPr lang="en-GB" noProof="0" dirty="0"/>
+              <a:t>Ship handling (Does it slide too much? Is the acceleration too slow?</a:t>
             </a:r>
           </a:p>
           <a:p>
             <a:pPr lvl="1"/>
             <a:r>
-              <a:rPr lang="cs-CZ" dirty="0" err="1"/>
-              <a:t>Scale</a:t>
-            </a:r>
-            <a:r>
-              <a:rPr lang="cs-CZ" dirty="0"/>
-              <a:t> (Are </a:t>
-            </a:r>
-            <a:r>
-              <a:rPr lang="cs-CZ" dirty="0" err="1"/>
-              <a:t>the</a:t>
-            </a:r>
-            <a:r>
-              <a:rPr lang="cs-CZ" dirty="0"/>
-              <a:t> </a:t>
-            </a:r>
-            <a:r>
-              <a:rPr lang="cs-CZ" dirty="0" err="1"/>
-              <a:t>checkpoints</a:t>
-            </a:r>
-            <a:r>
-              <a:rPr lang="cs-CZ" dirty="0"/>
-              <a:t> </a:t>
-            </a:r>
-            <a:r>
-              <a:rPr lang="cs-CZ" dirty="0" err="1"/>
-              <a:t>too</a:t>
-            </a:r>
-            <a:r>
-              <a:rPr lang="cs-CZ" dirty="0"/>
-              <a:t> </a:t>
-            </a:r>
-            <a:r>
-              <a:rPr lang="cs-CZ" dirty="0" err="1"/>
-              <a:t>small</a:t>
-            </a:r>
-            <a:r>
-              <a:rPr lang="cs-CZ" dirty="0"/>
-              <a:t>? </a:t>
-            </a:r>
-            <a:r>
-              <a:rPr lang="cs-CZ" dirty="0" err="1"/>
-              <a:t>Does</a:t>
-            </a:r>
-            <a:r>
-              <a:rPr lang="cs-CZ" dirty="0"/>
-              <a:t> </a:t>
-            </a:r>
-            <a:r>
-              <a:rPr lang="cs-CZ" dirty="0" err="1"/>
-              <a:t>the</a:t>
-            </a:r>
-            <a:r>
-              <a:rPr lang="cs-CZ" dirty="0"/>
-              <a:t> </a:t>
-            </a:r>
-            <a:r>
-              <a:rPr lang="cs-CZ" dirty="0" err="1"/>
-              <a:t>ship</a:t>
-            </a:r>
-            <a:r>
-              <a:rPr lang="cs-CZ" dirty="0"/>
-              <a:t> </a:t>
-            </a:r>
-            <a:r>
-              <a:rPr lang="cs-CZ" dirty="0" err="1"/>
-              <a:t>often</a:t>
-            </a:r>
-            <a:r>
-              <a:rPr lang="cs-CZ" dirty="0"/>
-              <a:t> </a:t>
-            </a:r>
-            <a:r>
-              <a:rPr lang="cs-CZ" dirty="0" err="1"/>
-              <a:t>get</a:t>
-            </a:r>
-            <a:r>
-              <a:rPr lang="cs-CZ" dirty="0"/>
-              <a:t> </a:t>
-            </a:r>
-            <a:r>
-              <a:rPr lang="cs-CZ" dirty="0" err="1"/>
-              <a:t>snagged</a:t>
-            </a:r>
-            <a:r>
-              <a:rPr lang="cs-CZ" dirty="0"/>
-              <a:t> on </a:t>
-            </a:r>
-            <a:r>
-              <a:rPr lang="cs-CZ" dirty="0" err="1"/>
-              <a:t>the</a:t>
-            </a:r>
-            <a:r>
-              <a:rPr lang="cs-CZ" dirty="0"/>
-              <a:t> checkpoint </a:t>
-            </a:r>
-            <a:r>
-              <a:rPr lang="cs-CZ" dirty="0" err="1"/>
-              <a:t>sides</a:t>
-            </a:r>
-            <a:r>
-              <a:rPr lang="cs-CZ" dirty="0"/>
-              <a:t>?)</a:t>
+              <a:rPr lang="en-GB" noProof="0" dirty="0"/>
+              <a:t>Scale (Are the checkpoints too small? Does the ship often get snagged on the checkpoint sides?)</a:t>
             </a:r>
           </a:p>
           <a:p>
             <a:pPr lvl="1"/>
             <a:r>
-              <a:rPr lang="cs-CZ" dirty="0" err="1"/>
-              <a:t>What</a:t>
-            </a:r>
-            <a:r>
-              <a:rPr lang="cs-CZ" dirty="0"/>
-              <a:t> UI are </a:t>
-            </a:r>
-            <a:r>
-              <a:rPr lang="cs-CZ" dirty="0" err="1"/>
-              <a:t>you</a:t>
-            </a:r>
-            <a:r>
-              <a:rPr lang="cs-CZ" dirty="0"/>
-              <a:t> </a:t>
-            </a:r>
-            <a:r>
-              <a:rPr lang="cs-CZ" dirty="0" err="1"/>
-              <a:t>missing</a:t>
-            </a:r>
-            <a:r>
-              <a:rPr lang="cs-CZ" dirty="0"/>
-              <a:t>? </a:t>
-            </a:r>
-            <a:r>
-              <a:rPr lang="cs-CZ" dirty="0" err="1"/>
-              <a:t>Pointers</a:t>
-            </a:r>
-            <a:r>
-              <a:rPr lang="cs-CZ" dirty="0"/>
-              <a:t> to </a:t>
-            </a:r>
-            <a:r>
-              <a:rPr lang="cs-CZ" dirty="0" err="1"/>
-              <a:t>the</a:t>
-            </a:r>
-            <a:r>
-              <a:rPr lang="cs-CZ" dirty="0"/>
-              <a:t> </a:t>
-            </a:r>
-            <a:r>
-              <a:rPr lang="cs-CZ" dirty="0" err="1"/>
-              <a:t>next</a:t>
-            </a:r>
-            <a:r>
-              <a:rPr lang="cs-CZ" dirty="0"/>
-              <a:t> checkpoint </a:t>
-            </a:r>
-            <a:r>
-              <a:rPr lang="cs-CZ" dirty="0" err="1"/>
-              <a:t>maybe</a:t>
-            </a:r>
-            <a:r>
-              <a:rPr lang="cs-CZ" dirty="0"/>
-              <a:t>? Centre-</a:t>
-            </a:r>
-            <a:r>
-              <a:rPr lang="cs-CZ" dirty="0" err="1"/>
-              <a:t>of</a:t>
-            </a:r>
-            <a:r>
-              <a:rPr lang="cs-CZ" dirty="0"/>
-              <a:t>-</a:t>
-            </a:r>
-            <a:r>
-              <a:rPr lang="cs-CZ" dirty="0" err="1"/>
-              <a:t>screen</a:t>
-            </a:r>
-            <a:r>
-              <a:rPr lang="cs-CZ" dirty="0"/>
-              <a:t> </a:t>
-            </a:r>
-            <a:r>
-              <a:rPr lang="cs-CZ" dirty="0" err="1"/>
-              <a:t>dot</a:t>
-            </a:r>
-            <a:r>
-              <a:rPr lang="cs-CZ" dirty="0"/>
-              <a:t>? </a:t>
-            </a:r>
-            <a:r>
-              <a:rPr lang="cs-CZ" dirty="0" err="1"/>
-              <a:t>Can</a:t>
-            </a:r>
-            <a:r>
-              <a:rPr lang="cs-CZ" dirty="0"/>
-              <a:t> </a:t>
-            </a:r>
-            <a:r>
-              <a:rPr lang="cs-CZ" dirty="0" err="1"/>
-              <a:t>you</a:t>
-            </a:r>
-            <a:r>
-              <a:rPr lang="cs-CZ" dirty="0"/>
-              <a:t> </a:t>
-            </a:r>
-            <a:r>
-              <a:rPr lang="cs-CZ" dirty="0" err="1"/>
-              <a:t>tell</a:t>
-            </a:r>
-            <a:r>
-              <a:rPr lang="cs-CZ" dirty="0"/>
-              <a:t> </a:t>
-            </a:r>
-            <a:r>
-              <a:rPr lang="cs-CZ" dirty="0" err="1"/>
-              <a:t>which</a:t>
-            </a:r>
-            <a:r>
-              <a:rPr lang="cs-CZ" dirty="0"/>
-              <a:t> </a:t>
-            </a:r>
-            <a:r>
-              <a:rPr lang="cs-CZ" dirty="0" err="1"/>
-              <a:t>way</a:t>
-            </a:r>
-            <a:r>
-              <a:rPr lang="cs-CZ" dirty="0"/>
-              <a:t> </a:t>
-            </a:r>
-            <a:r>
-              <a:rPr lang="cs-CZ" dirty="0" err="1"/>
-              <a:t>the</a:t>
-            </a:r>
-            <a:r>
-              <a:rPr lang="cs-CZ" dirty="0"/>
-              <a:t> </a:t>
-            </a:r>
-            <a:r>
-              <a:rPr lang="cs-CZ" dirty="0" err="1"/>
-              <a:t>ship</a:t>
-            </a:r>
-            <a:r>
-              <a:rPr lang="cs-CZ" dirty="0"/>
-              <a:t> </a:t>
-            </a:r>
-            <a:r>
-              <a:rPr lang="cs-CZ" dirty="0" err="1"/>
-              <a:t>is</a:t>
-            </a:r>
-            <a:r>
-              <a:rPr lang="cs-CZ" dirty="0"/>
-              <a:t> </a:t>
-            </a:r>
-            <a:r>
-              <a:rPr lang="cs-CZ" dirty="0" err="1"/>
-              <a:t>going</a:t>
-            </a:r>
-            <a:r>
-              <a:rPr lang="cs-CZ" dirty="0"/>
-              <a:t> to </a:t>
-            </a:r>
-            <a:r>
-              <a:rPr lang="cs-CZ" dirty="0" err="1"/>
-              <a:t>rotate</a:t>
-            </a:r>
-            <a:r>
-              <a:rPr lang="cs-CZ" dirty="0"/>
-              <a:t> via </a:t>
-            </a:r>
-            <a:r>
-              <a:rPr lang="cs-CZ" dirty="0" err="1"/>
-              <a:t>mouse</a:t>
-            </a:r>
-            <a:r>
-              <a:rPr lang="cs-CZ" dirty="0"/>
-              <a:t> </a:t>
-            </a:r>
-            <a:r>
-              <a:rPr lang="cs-CZ" dirty="0" err="1"/>
-              <a:t>controls</a:t>
-            </a:r>
-            <a:r>
-              <a:rPr lang="cs-CZ" dirty="0"/>
-              <a:t>?</a:t>
+              <a:rPr lang="en-GB" noProof="0" dirty="0"/>
+              <a:t>What UI are you missing? Pointers to the next checkpoint maybe? Centre-of-screen dot? Can you tell which way the ship is going to rotate via mouse controls?</a:t>
             </a:r>
           </a:p>
           <a:p>
             <a:pPr lvl="1"/>
             <a:r>
-              <a:rPr lang="cs-CZ" dirty="0" err="1"/>
-              <a:t>Did</a:t>
-            </a:r>
-            <a:r>
-              <a:rPr lang="cs-CZ" dirty="0"/>
-              <a:t> </a:t>
-            </a:r>
-            <a:r>
-              <a:rPr lang="cs-CZ" dirty="0" err="1"/>
-              <a:t>you</a:t>
-            </a:r>
-            <a:r>
-              <a:rPr lang="cs-CZ" dirty="0"/>
-              <a:t> </a:t>
-            </a:r>
-            <a:r>
-              <a:rPr lang="cs-CZ" dirty="0" err="1"/>
-              <a:t>get</a:t>
-            </a:r>
-            <a:r>
-              <a:rPr lang="cs-CZ" dirty="0"/>
-              <a:t> </a:t>
-            </a:r>
-            <a:r>
-              <a:rPr lang="cs-CZ" dirty="0" err="1"/>
-              <a:t>lost</a:t>
-            </a:r>
-            <a:r>
-              <a:rPr lang="cs-CZ" dirty="0"/>
-              <a:t> in any </a:t>
-            </a:r>
-            <a:r>
-              <a:rPr lang="cs-CZ" dirty="0" err="1"/>
-              <a:t>way</a:t>
-            </a:r>
-            <a:r>
-              <a:rPr lang="cs-CZ" dirty="0"/>
-              <a:t>?</a:t>
+              <a:rPr lang="en-GB" noProof="0" dirty="0"/>
+              <a:t>Did you get lost in any way?</a:t>
             </a:r>
           </a:p>
           <a:p>
             <a:pPr lvl="1"/>
             <a:r>
-              <a:rPr lang="cs-CZ" dirty="0" err="1"/>
-              <a:t>Is</a:t>
-            </a:r>
-            <a:r>
-              <a:rPr lang="cs-CZ" dirty="0"/>
-              <a:t> </a:t>
-            </a:r>
-            <a:r>
-              <a:rPr lang="cs-CZ" dirty="0" err="1"/>
-              <a:t>the</a:t>
-            </a:r>
-            <a:r>
-              <a:rPr lang="cs-CZ" dirty="0"/>
-              <a:t> </a:t>
-            </a:r>
-            <a:r>
-              <a:rPr lang="cs-CZ" dirty="0" err="1"/>
+              <a:rPr lang="en-GB" noProof="0" dirty="0"/>
+              <a:t>Is the </a:t>
+            </a:r>
+            <a:r>
+              <a:rPr lang="en-GB" noProof="0" dirty="0" err="1"/>
               <a:t>color</a:t>
             </a:r>
             <a:r>
-              <a:rPr lang="cs-CZ" dirty="0"/>
-              <a:t> </a:t>
-            </a:r>
-            <a:r>
-              <a:rPr lang="cs-CZ" dirty="0" err="1"/>
-              <a:t>scheme</a:t>
-            </a:r>
-            <a:r>
-              <a:rPr lang="cs-CZ" dirty="0"/>
-              <a:t> OK and </a:t>
-            </a:r>
-            <a:r>
-              <a:rPr lang="cs-CZ" dirty="0" err="1"/>
-              <a:t>if</a:t>
-            </a:r>
-            <a:r>
-              <a:rPr lang="cs-CZ" dirty="0"/>
-              <a:t> not, </a:t>
-            </a:r>
-            <a:r>
-              <a:rPr lang="cs-CZ" dirty="0" err="1"/>
-              <a:t>what</a:t>
-            </a:r>
-            <a:r>
-              <a:rPr lang="cs-CZ" dirty="0"/>
-              <a:t> </a:t>
-            </a:r>
-            <a:r>
-              <a:rPr lang="cs-CZ" dirty="0" err="1"/>
-              <a:t>was</a:t>
-            </a:r>
-            <a:r>
-              <a:rPr lang="cs-CZ" dirty="0"/>
-              <a:t> hard to </a:t>
-            </a:r>
-            <a:r>
-              <a:rPr lang="cs-CZ" dirty="0" err="1"/>
-              <a:t>see</a:t>
-            </a:r>
-            <a:r>
-              <a:rPr lang="cs-CZ" dirty="0"/>
-              <a:t>?</a:t>
-            </a:r>
-          </a:p>
-          <a:p>
-            <a:r>
-              <a:rPr lang="cs-CZ" dirty="0" err="1"/>
-              <a:t>If</a:t>
-            </a:r>
-            <a:r>
-              <a:rPr lang="cs-CZ" dirty="0"/>
-              <a:t> </a:t>
-            </a:r>
-            <a:r>
-              <a:rPr lang="cs-CZ" dirty="0" err="1"/>
-              <a:t>you</a:t>
-            </a:r>
-            <a:r>
-              <a:rPr lang="cs-CZ" dirty="0"/>
-              <a:t> </a:t>
-            </a:r>
-            <a:r>
-              <a:rPr lang="cs-CZ" dirty="0" err="1"/>
-              <a:t>wanted</a:t>
-            </a:r>
-            <a:r>
-              <a:rPr lang="cs-CZ" dirty="0"/>
-              <a:t> a </a:t>
-            </a:r>
-            <a:r>
-              <a:rPr lang="cs-CZ" dirty="0" err="1"/>
-              <a:t>feature</a:t>
-            </a:r>
-            <a:r>
-              <a:rPr lang="cs-CZ" dirty="0"/>
-              <a:t> to make </a:t>
-            </a:r>
-            <a:r>
-              <a:rPr lang="cs-CZ" dirty="0" err="1"/>
-              <a:t>the</a:t>
-            </a:r>
-            <a:r>
-              <a:rPr lang="cs-CZ" dirty="0"/>
-              <a:t> game </a:t>
-            </a:r>
-            <a:r>
-              <a:rPr lang="cs-CZ" dirty="0" err="1"/>
-              <a:t>feel</a:t>
-            </a:r>
-            <a:r>
-              <a:rPr lang="cs-CZ" dirty="0"/>
-              <a:t> </a:t>
-            </a:r>
-            <a:r>
-              <a:rPr lang="cs-CZ" dirty="0" err="1"/>
-              <a:t>nicer</a:t>
-            </a:r>
-            <a:r>
-              <a:rPr lang="cs-CZ" dirty="0"/>
-              <a:t>, </a:t>
-            </a:r>
-            <a:r>
-              <a:rPr lang="cs-CZ" dirty="0" err="1"/>
-              <a:t>what</a:t>
-            </a:r>
-            <a:r>
-              <a:rPr lang="cs-CZ" dirty="0"/>
-              <a:t> </a:t>
-            </a:r>
-            <a:r>
-              <a:rPr lang="cs-CZ" dirty="0" err="1"/>
-              <a:t>would</a:t>
-            </a:r>
-            <a:r>
-              <a:rPr lang="cs-CZ" dirty="0"/>
-              <a:t> </a:t>
-            </a:r>
-            <a:r>
-              <a:rPr lang="cs-CZ" dirty="0" err="1"/>
-              <a:t>it</a:t>
-            </a:r>
-            <a:r>
-              <a:rPr lang="cs-CZ" dirty="0"/>
-              <a:t> </a:t>
-            </a:r>
-            <a:r>
-              <a:rPr lang="cs-CZ" dirty="0" err="1"/>
-              <a:t>be</a:t>
-            </a:r>
-            <a:r>
-              <a:rPr lang="cs-CZ" dirty="0"/>
-              <a:t>?</a:t>
+              <a:rPr lang="en-GB" noProof="0" dirty="0"/>
+              <a:t> scheme OK and if not, what was hard to see?</a:t>
+            </a:r>
+          </a:p>
+          <a:p>
+            <a:r>
+              <a:rPr lang="en-GB" noProof="0" dirty="0"/>
+              <a:t>If you wanted a feature to make the game feel nicer, what would it be?</a:t>
             </a:r>
           </a:p>
           <a:p>
             <a:pPr lvl="1"/>
             <a:r>
-              <a:rPr lang="cs-CZ" dirty="0"/>
+              <a:rPr lang="en-GB" noProof="0" dirty="0"/>
               <a:t>Music?</a:t>
             </a:r>
           </a:p>
           <a:p>
             <a:pPr lvl="1"/>
             <a:r>
-              <a:rPr lang="cs-CZ" dirty="0" err="1"/>
-              <a:t>Dynamic</a:t>
-            </a:r>
-            <a:r>
-              <a:rPr lang="cs-CZ" dirty="0"/>
-              <a:t> </a:t>
-            </a:r>
-            <a:r>
-              <a:rPr lang="cs-CZ" dirty="0" err="1"/>
-              <a:t>camera</a:t>
-            </a:r>
-            <a:r>
-              <a:rPr lang="cs-CZ" dirty="0"/>
-              <a:t> so </a:t>
-            </a:r>
-            <a:r>
-              <a:rPr lang="cs-CZ" dirty="0" err="1"/>
-              <a:t>it</a:t>
-            </a:r>
-            <a:r>
-              <a:rPr lang="cs-CZ" dirty="0"/>
-              <a:t> </a:t>
-            </a:r>
-            <a:r>
-              <a:rPr lang="cs-CZ" dirty="0" err="1"/>
-              <a:t>feels</a:t>
-            </a:r>
-            <a:r>
-              <a:rPr lang="cs-CZ" dirty="0"/>
-              <a:t> </a:t>
-            </a:r>
-            <a:r>
-              <a:rPr lang="cs-CZ" dirty="0" err="1"/>
-              <a:t>like</a:t>
-            </a:r>
-            <a:r>
-              <a:rPr lang="cs-CZ" dirty="0"/>
-              <a:t> </a:t>
-            </a:r>
-            <a:r>
-              <a:rPr lang="cs-CZ" dirty="0" err="1"/>
-              <a:t>first</a:t>
-            </a:r>
-            <a:r>
-              <a:rPr lang="cs-CZ" dirty="0"/>
-              <a:t> </a:t>
-            </a:r>
-            <a:r>
-              <a:rPr lang="cs-CZ" dirty="0" err="1"/>
-              <a:t>pirson</a:t>
-            </a:r>
-            <a:r>
-              <a:rPr lang="cs-CZ" dirty="0"/>
-              <a:t> </a:t>
-            </a:r>
-            <a:r>
-              <a:rPr lang="cs-CZ" dirty="0" err="1"/>
-              <a:t>instead</a:t>
-            </a:r>
-            <a:r>
-              <a:rPr lang="cs-CZ" dirty="0"/>
-              <a:t> </a:t>
-            </a:r>
-            <a:r>
-              <a:rPr lang="cs-CZ" dirty="0" err="1"/>
-              <a:t>of</a:t>
-            </a:r>
-            <a:r>
-              <a:rPr lang="cs-CZ" dirty="0"/>
-              <a:t> a </a:t>
-            </a:r>
-            <a:r>
-              <a:rPr lang="cs-CZ" dirty="0" err="1"/>
-              <a:t>camera</a:t>
-            </a:r>
-            <a:r>
-              <a:rPr lang="cs-CZ" dirty="0"/>
-              <a:t> </a:t>
-            </a:r>
-            <a:r>
-              <a:rPr lang="cs-CZ" dirty="0" err="1"/>
-              <a:t>maybe</a:t>
-            </a:r>
-            <a:r>
-              <a:rPr lang="cs-CZ" dirty="0"/>
-              <a:t>?</a:t>
+              <a:rPr lang="en-GB" noProof="0" dirty="0"/>
+              <a:t>Dynamic camera so it feels like first person instead of a camera maybe?</a:t>
             </a:r>
           </a:p>
           <a:p>
             <a:pPr lvl="1"/>
             <a:r>
-              <a:rPr lang="cs-CZ" dirty="0"/>
-              <a:t>Time </a:t>
-            </a:r>
-            <a:r>
-              <a:rPr lang="cs-CZ" dirty="0" err="1"/>
-              <a:t>splits</a:t>
-            </a:r>
-            <a:r>
-              <a:rPr lang="cs-CZ" dirty="0"/>
-              <a:t>?</a:t>
+              <a:rPr lang="en-GB" noProof="0" dirty="0"/>
+              <a:t>Time splits?</a:t>
             </a:r>
           </a:p>
           <a:p>
             <a:pPr lvl="1"/>
             <a:r>
-              <a:rPr lang="cs-CZ" dirty="0"/>
-              <a:t>Or a </a:t>
-            </a:r>
-            <a:r>
-              <a:rPr lang="cs-CZ" dirty="0" err="1"/>
-              <a:t>hotkey</a:t>
-            </a:r>
-            <a:r>
-              <a:rPr lang="cs-CZ" dirty="0"/>
-              <a:t> </a:t>
-            </a:r>
-            <a:r>
-              <a:rPr lang="cs-CZ" dirty="0" err="1"/>
-              <a:t>for</a:t>
-            </a:r>
-            <a:r>
-              <a:rPr lang="cs-CZ" dirty="0"/>
-              <a:t> </a:t>
-            </a:r>
-            <a:r>
-              <a:rPr lang="cs-CZ" dirty="0" err="1"/>
-              <a:t>some</a:t>
-            </a:r>
-            <a:r>
-              <a:rPr lang="cs-CZ" dirty="0"/>
-              <a:t> </a:t>
-            </a:r>
-            <a:r>
-              <a:rPr lang="cs-CZ" dirty="0" err="1"/>
-              <a:t>control</a:t>
-            </a:r>
-            <a:r>
-              <a:rPr lang="cs-CZ" dirty="0"/>
-              <a:t> </a:t>
-            </a:r>
-            <a:r>
-              <a:rPr lang="cs-CZ" dirty="0" err="1"/>
-              <a:t>function</a:t>
-            </a:r>
-            <a:r>
-              <a:rPr lang="cs-CZ" dirty="0"/>
-              <a:t>?</a:t>
+              <a:rPr lang="en-GB" noProof="0" dirty="0"/>
+              <a:t>Or a hotkey for some control function?</a:t>
             </a:r>
           </a:p>
           <a:p>

</xml_diff>